<commit_message>
Remove Google Colab references
</commit_message>
<xml_diff>
--- a/ETF_effects_The_role_of_primary_versus_secondary_market_activities/etf_effects_presentation.pptx
+++ b/ETF_effects_The_role_of_primary_versus_secondary_market_activities/etf_effects_presentation.pptx
@@ -126,7 +126,7 @@
   <p:extLst>
     <p:ext uri="{521415D9-36F7-43E2-AB2F-B90AF26B5E84}">
       <p14:sectionLst xmlns:p14="http://schemas.microsoft.com/office/powerpoint/2010/main">
-        <p14:section name="Introduction" id="{6a92a72b-61a9-2074-d1e7-c075134229a2}">
+        <p14:section name="Introduction" id="{75d498f1-6a0b-05eb-6583-9275ff02a1df}">
           <p14:sldIdLst>
             <p14:sldId id="256"/>
             <p14:sldId id="257"/>
@@ -134,7 +134,7 @@
             <p14:sldId id="259"/>
           </p14:sldIdLst>
         </p14:section>
-        <p14:section name="The paper" id="{a1c31d9b-931d-93a9-a21e-8404023c3f29}">
+        <p14:section name="The paper" id="{72e2697b-9348-8a9b-e314-b5e9c058a9eb}">
           <p14:sldIdLst>
             <p14:sldId id="260"/>
             <p14:sldId id="261"/>
@@ -147,14 +147,14 @@
             <p14:sldId id="268"/>
           </p14:sldIdLst>
         </p14:section>
-        <p14:section name="Our replication" id="{e986c59c-f3f2-981a-178e-ff54af37cc38}">
+        <p14:section name="Our replication" id="{934c74a4-990e-ffcb-ac3f-d4f0e060ea06}">
           <p14:sldIdLst>
             <p14:sldId id="269"/>
             <p14:sldId id="270"/>
             <p14:sldId id="271"/>
           </p14:sldIdLst>
         </p14:section>
-        <p14:section name="Discussion" id="{85ae81ce-07e0-33ff-179e-a5ac6101a0e2}">
+        <p14:section name="Discussion" id="{497f311c-a605-d1a6-fa74-42443933a885}">
           <p14:sldIdLst>
             <p14:sldId id="272"/>
             <p14:sldId id="273"/>
@@ -8596,7 +8596,7 @@
                   <a:schemeClr val="tx1"/>
                 </a:solidFill>
               </a:rPr>
-              <a:t>real-data modules for Colab (a dose–response test across BoJ regimes, with a 2021–24 placebo, and a tick-size-controlled trend) ready to run on BoJ statistics and Yahoo Finance data.</a:t>
+              <a:t>real-data modules (a dose–response test across BoJ regimes, with a 2021–24 placebo, and a tick-size-controlled trend) ready to run on BoJ statistics and Yahoo Finance data.</a:t>
             </a:r>
             <a:endParaRPr lang="en-US" sz="1500" dirty="0"/>
           </a:p>

</xml_diff>